<commit_message>
Soutenance : notes présentateur avec minutage (15 min)
</commit_message>
<xml_diff>
--- a/Soutenance_Loup-Garou.pptx
+++ b/Soutenance_Loup-Garou.pptx
@@ -115,6 +115,1443 @@
     </a:lvl9pPr>
   </p:defaultTextStyle>
 </p:presentation>
+</file>
+
+<file path=ppt/notesMasters/notesMaster1.xml><?xml version="1.0" encoding="utf-8"?>
+<p:notesMaster xmlns:a="http://schemas.openxmlformats.org/drawingml/2006/main" xmlns:p="http://schemas.openxmlformats.org/presentationml/2006/main" xmlns:r="http://schemas.openxmlformats.org/officeDocument/2006/relationships">
+  <p:cSld>
+    <p:bg>
+      <p:bgRef idx="1001">
+        <a:schemeClr val="bg1"/>
+      </p:bgRef>
+    </p:bg>
+    <p:spTree>
+      <p:nvGrpSpPr>
+        <p:cNvPr id="1" name=""/>
+        <p:cNvGrpSpPr/>
+        <p:nvPr/>
+      </p:nvGrpSpPr>
+      <p:grpSpPr>
+        <a:xfrm>
+          <a:off x="0" y="0"/>
+          <a:ext cx="0" cy="0"/>
+          <a:chOff x="0" y="0"/>
+          <a:chExt cx="0" cy="0"/>
+        </a:xfrm>
+      </p:grpSpPr>
+      <p:sp>
+        <p:nvSpPr>
+          <p:cNvPr id="2" name="Header Placeholder 1"/>
+          <p:cNvSpPr>
+            <a:spLocks noGrp="1"/>
+          </p:cNvSpPr>
+          <p:nvPr>
+            <p:ph type="hdr" sz="quarter"/>
+          </p:nvPr>
+        </p:nvSpPr>
+        <p:spPr>
+          <a:xfrm>
+            <a:off x="0" y="0"/>
+            <a:ext cx="2971800" cy="457200"/>
+          </a:xfrm>
+          <a:prstGeom prst="rect">
+            <a:avLst/>
+          </a:prstGeom>
+        </p:spPr>
+        <p:txBody>
+          <a:bodyPr vert="horz" lIns="91440" tIns="45720" rIns="91440" bIns="45720" rtlCol="0"/>
+          <a:lstStyle>
+            <a:lvl1pPr algn="l">
+              <a:defRPr sz="1200"/>
+            </a:lvl1pPr>
+          </a:lstStyle>
+          <a:p>
+            <a:endParaRPr lang="en-US"/>
+          </a:p>
+        </p:txBody>
+      </p:sp>
+      <p:sp>
+        <p:nvSpPr>
+          <p:cNvPr id="3" name="Date Placeholder 2"/>
+          <p:cNvSpPr>
+            <a:spLocks noGrp="1"/>
+          </p:cNvSpPr>
+          <p:nvPr>
+            <p:ph type="dt" idx="1"/>
+          </p:nvPr>
+        </p:nvSpPr>
+        <p:spPr>
+          <a:xfrm>
+            <a:off x="3884613" y="0"/>
+            <a:ext cx="2971800" cy="457200"/>
+          </a:xfrm>
+          <a:prstGeom prst="rect">
+            <a:avLst/>
+          </a:prstGeom>
+        </p:spPr>
+        <p:txBody>
+          <a:bodyPr vert="horz" lIns="91440" tIns="45720" rIns="91440" bIns="45720" rtlCol="0"/>
+          <a:lstStyle>
+            <a:lvl1pPr algn="r">
+              <a:defRPr sz="1200"/>
+            </a:lvl1pPr>
+          </a:lstStyle>
+          <a:p>
+            <a:fld id="{0F89C1C7-3DCD-1040-A9CF-14679D8B5DDD}" type="datetimeFigureOut">
+              <a:rPr lang="en-US" smtClean="0"/>
+              <a:t>10/17/16</a:t>
+            </a:fld>
+            <a:endParaRPr lang="en-US"/>
+          </a:p>
+        </p:txBody>
+      </p:sp>
+      <p:sp>
+        <p:nvSpPr>
+          <p:cNvPr id="4" name="Slide Image Placeholder 3"/>
+          <p:cNvSpPr>
+            <a:spLocks noGrp="1" noRot="1" noChangeAspect="1"/>
+          </p:cNvSpPr>
+          <p:nvPr>
+            <p:ph type="sldImg" idx="2"/>
+          </p:nvPr>
+        </p:nvSpPr>
+        <p:spPr>
+          <a:xfrm>
+            <a:off x="1143000" y="685800"/>
+            <a:ext cx="4572000" cy="3429000"/>
+          </a:xfrm>
+          <a:prstGeom prst="rect">
+            <a:avLst/>
+          </a:prstGeom>
+          <a:noFill/>
+          <a:ln w="12700">
+            <a:solidFill>
+              <a:prstClr val="black"/>
+            </a:solidFill>
+          </a:ln>
+        </p:spPr>
+        <p:txBody>
+          <a:bodyPr vert="horz" lIns="91440" tIns="45720" rIns="91440" bIns="45720" rtlCol="0" anchor="ctr"/>
+          <a:lstStyle/>
+          <a:p>
+            <a:endParaRPr lang="en-US"/>
+          </a:p>
+        </p:txBody>
+      </p:sp>
+      <p:sp>
+        <p:nvSpPr>
+          <p:cNvPr id="5" name="Notes Placeholder 4"/>
+          <p:cNvSpPr>
+            <a:spLocks noGrp="1"/>
+          </p:cNvSpPr>
+          <p:nvPr>
+            <p:ph type="body" sz="quarter" idx="3"/>
+          </p:nvPr>
+        </p:nvSpPr>
+        <p:spPr>
+          <a:xfrm>
+            <a:off x="685800" y="4343400"/>
+            <a:ext cx="5486400" cy="4114800"/>
+          </a:xfrm>
+          <a:prstGeom prst="rect">
+            <a:avLst/>
+          </a:prstGeom>
+        </p:spPr>
+        <p:txBody>
+          <a:bodyPr vert="horz" lIns="91440" tIns="45720" rIns="91440" bIns="45720" rtlCol="0"/>
+          <a:lstStyle/>
+          <a:p>
+            <a:pPr lvl="0"/>
+            <a:r>
+              <a:rPr lang="en-US" smtClean="0"/>
+              <a:t>Click to edit Master text styles</a:t>
+            </a:r>
+          </a:p>
+          <a:p>
+            <a:pPr lvl="1"/>
+            <a:r>
+              <a:rPr lang="en-US" smtClean="0"/>
+              <a:t>Second level</a:t>
+            </a:r>
+          </a:p>
+          <a:p>
+            <a:pPr lvl="2"/>
+            <a:r>
+              <a:rPr lang="en-US" smtClean="0"/>
+              <a:t>Third level</a:t>
+            </a:r>
+          </a:p>
+          <a:p>
+            <a:pPr lvl="3"/>
+            <a:r>
+              <a:rPr lang="en-US" smtClean="0"/>
+              <a:t>Fourth level</a:t>
+            </a:r>
+          </a:p>
+          <a:p>
+            <a:pPr lvl="4"/>
+            <a:r>
+              <a:rPr lang="en-US" smtClean="0"/>
+              <a:t>Fifth level</a:t>
+            </a:r>
+            <a:endParaRPr lang="en-US"/>
+          </a:p>
+        </p:txBody>
+      </p:sp>
+      <p:sp>
+        <p:nvSpPr>
+          <p:cNvPr id="6" name="Footer Placeholder 5"/>
+          <p:cNvSpPr>
+            <a:spLocks noGrp="1"/>
+          </p:cNvSpPr>
+          <p:nvPr>
+            <p:ph type="ftr" sz="quarter" idx="4"/>
+          </p:nvPr>
+        </p:nvSpPr>
+        <p:spPr>
+          <a:xfrm>
+            <a:off x="0" y="8685213"/>
+            <a:ext cx="2971800" cy="457200"/>
+          </a:xfrm>
+          <a:prstGeom prst="rect">
+            <a:avLst/>
+          </a:prstGeom>
+        </p:spPr>
+        <p:txBody>
+          <a:bodyPr vert="horz" lIns="91440" tIns="45720" rIns="91440" bIns="45720" rtlCol="0" anchor="b"/>
+          <a:lstStyle>
+            <a:lvl1pPr algn="l">
+              <a:defRPr sz="1200"/>
+            </a:lvl1pPr>
+          </a:lstStyle>
+          <a:p>
+            <a:endParaRPr lang="en-US"/>
+          </a:p>
+        </p:txBody>
+      </p:sp>
+      <p:sp>
+        <p:nvSpPr>
+          <p:cNvPr id="7" name="Slide Number Placeholder 6"/>
+          <p:cNvSpPr>
+            <a:spLocks noGrp="1"/>
+          </p:cNvSpPr>
+          <p:nvPr>
+            <p:ph type="sldNum" sz="quarter" idx="5"/>
+          </p:nvPr>
+        </p:nvSpPr>
+        <p:spPr>
+          <a:xfrm>
+            <a:off x="3884613" y="8685213"/>
+            <a:ext cx="2971800" cy="457200"/>
+          </a:xfrm>
+          <a:prstGeom prst="rect">
+            <a:avLst/>
+          </a:prstGeom>
+        </p:spPr>
+        <p:txBody>
+          <a:bodyPr vert="horz" lIns="91440" tIns="45720" rIns="91440" bIns="45720" rtlCol="0" anchor="b"/>
+          <a:lstStyle>
+            <a:lvl1pPr algn="r">
+              <a:defRPr sz="1200"/>
+            </a:lvl1pPr>
+          </a:lstStyle>
+          <a:p>
+            <a:fld id="{BB5E49A5-4136-284D-997B-48E1D791AD67}" type="slidenum">
+              <a:rPr lang="en-US" smtClean="0"/>
+              <a:t>‹#›</a:t>
+            </a:fld>
+            <a:endParaRPr lang="en-US"/>
+          </a:p>
+        </p:txBody>
+      </p:sp>
+    </p:spTree>
+    <p:extLst>
+      <p:ext uri="{BB962C8B-B14F-4D97-AF65-F5344CB8AC3E}">
+        <p14:creationId xmlns:p14="http://schemas.microsoft.com/office/powerpoint/2010/main" val="2623252185"/>
+      </p:ext>
+    </p:extLst>
+  </p:cSld>
+  <p:clrMap bg1="lt1" tx1="dk1" bg2="lt2" tx2="dk2" accent1="accent1" accent2="accent2" accent3="accent3" accent4="accent4" accent5="accent5" accent6="accent6" hlink="hlink" folHlink="folHlink"/>
+  <p:notesStyle>
+    <a:lvl1pPr marL="0" algn="l" defTabSz="457200" rtl="0" eaLnBrk="1" latinLnBrk="0" hangingPunct="1">
+      <a:defRPr sz="1200" kern="1200">
+        <a:solidFill>
+          <a:schemeClr val="tx1"/>
+        </a:solidFill>
+        <a:latin typeface="+mn-lt"/>
+        <a:ea typeface="+mn-ea"/>
+        <a:cs typeface="+mn-cs"/>
+      </a:defRPr>
+    </a:lvl1pPr>
+    <a:lvl2pPr marL="457200" algn="l" defTabSz="457200" rtl="0" eaLnBrk="1" latinLnBrk="0" hangingPunct="1">
+      <a:defRPr sz="1200" kern="1200">
+        <a:solidFill>
+          <a:schemeClr val="tx1"/>
+        </a:solidFill>
+        <a:latin typeface="+mn-lt"/>
+        <a:ea typeface="+mn-ea"/>
+        <a:cs typeface="+mn-cs"/>
+      </a:defRPr>
+    </a:lvl2pPr>
+    <a:lvl3pPr marL="914400" algn="l" defTabSz="457200" rtl="0" eaLnBrk="1" latinLnBrk="0" hangingPunct="1">
+      <a:defRPr sz="1200" kern="1200">
+        <a:solidFill>
+          <a:schemeClr val="tx1"/>
+        </a:solidFill>
+        <a:latin typeface="+mn-lt"/>
+        <a:ea typeface="+mn-ea"/>
+        <a:cs typeface="+mn-cs"/>
+      </a:defRPr>
+    </a:lvl3pPr>
+    <a:lvl4pPr marL="1371600" algn="l" defTabSz="457200" rtl="0" eaLnBrk="1" latinLnBrk="0" hangingPunct="1">
+      <a:defRPr sz="1200" kern="1200">
+        <a:solidFill>
+          <a:schemeClr val="tx1"/>
+        </a:solidFill>
+        <a:latin typeface="+mn-lt"/>
+        <a:ea typeface="+mn-ea"/>
+        <a:cs typeface="+mn-cs"/>
+      </a:defRPr>
+    </a:lvl4pPr>
+    <a:lvl5pPr marL="1828800" algn="l" defTabSz="457200" rtl="0" eaLnBrk="1" latinLnBrk="0" hangingPunct="1">
+      <a:defRPr sz="1200" kern="1200">
+        <a:solidFill>
+          <a:schemeClr val="tx1"/>
+        </a:solidFill>
+        <a:latin typeface="+mn-lt"/>
+        <a:ea typeface="+mn-ea"/>
+        <a:cs typeface="+mn-cs"/>
+      </a:defRPr>
+    </a:lvl5pPr>
+    <a:lvl6pPr marL="2286000" algn="l" defTabSz="457200" rtl="0" eaLnBrk="1" latinLnBrk="0" hangingPunct="1">
+      <a:defRPr sz="1200" kern="1200">
+        <a:solidFill>
+          <a:schemeClr val="tx1"/>
+        </a:solidFill>
+        <a:latin typeface="+mn-lt"/>
+        <a:ea typeface="+mn-ea"/>
+        <a:cs typeface="+mn-cs"/>
+      </a:defRPr>
+    </a:lvl6pPr>
+    <a:lvl7pPr marL="2743200" algn="l" defTabSz="457200" rtl="0" eaLnBrk="1" latinLnBrk="0" hangingPunct="1">
+      <a:defRPr sz="1200" kern="1200">
+        <a:solidFill>
+          <a:schemeClr val="tx1"/>
+        </a:solidFill>
+        <a:latin typeface="+mn-lt"/>
+        <a:ea typeface="+mn-ea"/>
+        <a:cs typeface="+mn-cs"/>
+      </a:defRPr>
+    </a:lvl7pPr>
+    <a:lvl8pPr marL="3200400" algn="l" defTabSz="457200" rtl="0" eaLnBrk="1" latinLnBrk="0" hangingPunct="1">
+      <a:defRPr sz="1200" kern="1200">
+        <a:solidFill>
+          <a:schemeClr val="tx1"/>
+        </a:solidFill>
+        <a:latin typeface="+mn-lt"/>
+        <a:ea typeface="+mn-ea"/>
+        <a:cs typeface="+mn-cs"/>
+      </a:defRPr>
+    </a:lvl8pPr>
+    <a:lvl9pPr marL="3657600" algn="l" defTabSz="457200" rtl="0" eaLnBrk="1" latinLnBrk="0" hangingPunct="1">
+      <a:defRPr sz="1200" kern="1200">
+        <a:solidFill>
+          <a:schemeClr val="tx1"/>
+        </a:solidFill>
+        <a:latin typeface="+mn-lt"/>
+        <a:ea typeface="+mn-ea"/>
+        <a:cs typeface="+mn-cs"/>
+      </a:defRPr>
+    </a:lvl9pPr>
+  </p:notesStyle>
+</p:notesMaster>
+</file>
+
+<file path=ppt/notesSlides/notesSlide1.xml><?xml version="1.0" encoding="utf-8"?>
+<p:notes xmlns:a="http://schemas.openxmlformats.org/drawingml/2006/main" xmlns:p="http://schemas.openxmlformats.org/presentationml/2006/main" xmlns:r="http://schemas.openxmlformats.org/officeDocument/2006/relationships">
+  <p:cSld>
+    <p:spTree>
+      <p:nvGrpSpPr>
+        <p:cNvPr id="1" name=""/>
+        <p:cNvGrpSpPr/>
+        <p:nvPr/>
+      </p:nvGrpSpPr>
+      <p:grpSpPr>
+        <a:xfrm>
+          <a:off x="0" y="0"/>
+          <a:ext cx="0" cy="0"/>
+          <a:chOff x="0" y="0"/>
+          <a:chExt cx="0" cy="0"/>
+        </a:xfrm>
+      </p:grpSpPr>
+      <p:sp>
+        <p:nvSpPr>
+          <p:cNvPr id="2" name="Slide Image Placeholder 1"/>
+          <p:cNvSpPr>
+            <a:spLocks noGrp="1"/>
+          </p:cNvSpPr>
+          <p:nvPr>
+            <p:ph type="sldImg" idx="2"/>
+          </p:nvPr>
+        </p:nvSpPr>
+        <p:spPr/>
+      </p:sp>
+      <p:sp>
+        <p:nvSpPr>
+          <p:cNvPr id="3" name="Notes Placeholder 2"/>
+          <p:cNvSpPr>
+            <a:spLocks noGrp="1"/>
+          </p:cNvSpPr>
+          <p:nvPr>
+            <p:ph type="body" idx="3" sz="quarter"/>
+          </p:nvPr>
+        </p:nvSpPr>
+        <p:spPr/>
+        <p:txBody>
+          <a:bodyPr/>
+          <a:lstStyle/>
+          <a:p>
+            <a:r>
+              <a:t>⏱ 30 secondes  (cumul : 0:30)</a:t>
+            </a:r>
+          </a:p>
+          <a:p/>
+          <a:p>
+            <a:r>
+              <a:t>Bonjour, je vais vous présenter mon projet : une adaptation multijoueur du Loup-Garou de Thiercelieux, en client lourd.</a:t>
+            </a:r>
+          </a:p>
+          <a:p/>
+          <a:p>
+            <a:r>
+              <a:t>C'est un projet que j'ai réalisé seul : le client JavaFX, l'API PHP et la base de données.</a:t>
+            </a:r>
+          </a:p>
+          <a:p/>
+          <a:p>
+            <a:r>
+              <a:t>Annonce du plan : le jeu, l'architecture, la technique, les difficultés, puis la démo live.</a:t>
+            </a:r>
+          </a:p>
+        </p:txBody>
+      </p:sp>
+      <p:sp>
+        <p:nvSpPr>
+          <p:cNvPr id="4" name="Slide Number Placeholder 3"/>
+          <p:cNvSpPr>
+            <a:spLocks noGrp="1"/>
+          </p:cNvSpPr>
+          <p:nvPr>
+            <p:ph type="sldNum" idx="5" sz="quarter"/>
+          </p:nvPr>
+        </p:nvSpPr>
+        <p:spPr/>
+      </p:sp>
+    </p:spTree>
+  </p:cSld>
+  <p:clrMapOvr>
+    <a:masterClrMapping/>
+  </p:clrMapOvr>
+</p:notes>
+</file>
+
+<file path=ppt/notesSlides/notesSlide10.xml><?xml version="1.0" encoding="utf-8"?>
+<p:notes xmlns:a="http://schemas.openxmlformats.org/drawingml/2006/main" xmlns:p="http://schemas.openxmlformats.org/presentationml/2006/main" xmlns:r="http://schemas.openxmlformats.org/officeDocument/2006/relationships">
+  <p:cSld>
+    <p:spTree>
+      <p:nvGrpSpPr>
+        <p:cNvPr id="1" name=""/>
+        <p:cNvGrpSpPr/>
+        <p:nvPr/>
+      </p:nvGrpSpPr>
+      <p:grpSpPr>
+        <a:xfrm>
+          <a:off x="0" y="0"/>
+          <a:ext cx="0" cy="0"/>
+          <a:chOff x="0" y="0"/>
+          <a:chExt cx="0" cy="0"/>
+        </a:xfrm>
+      </p:grpSpPr>
+      <p:sp>
+        <p:nvSpPr>
+          <p:cNvPr id="2" name="Slide Image Placeholder 1"/>
+          <p:cNvSpPr>
+            <a:spLocks noGrp="1"/>
+          </p:cNvSpPr>
+          <p:nvPr>
+            <p:ph type="sldImg" idx="2"/>
+          </p:nvPr>
+        </p:nvSpPr>
+        <p:spPr/>
+      </p:sp>
+      <p:sp>
+        <p:nvSpPr>
+          <p:cNvPr id="3" name="Notes Placeholder 2"/>
+          <p:cNvSpPr>
+            <a:spLocks noGrp="1"/>
+          </p:cNvSpPr>
+          <p:nvPr>
+            <p:ph type="body" idx="3" sz="quarter"/>
+          </p:nvPr>
+        </p:nvSpPr>
+        <p:spPr/>
+        <p:txBody>
+          <a:bodyPr/>
+          <a:lstStyle/>
+          <a:p>
+            <a:r>
+              <a:t>⏱ 30 secondes  (cumul : 14:30)</a:t>
+            </a:r>
+          </a:p>
+          <a:p/>
+          <a:p>
+            <a:r>
+              <a:t>Transition vers la démo — annoncer simplement le programme des 4 étapes et les points à observer (colonne de droite).</a:t>
+            </a:r>
+          </a:p>
+          <a:p/>
+          <a:p>
+            <a:r>
+              <a:t>Logistique déjà prête : demo.bat lance la BDD, l'API et les 4 fenêtres d'un coup.</a:t>
+            </a:r>
+          </a:p>
+          <a:p/>
+          <a:p>
+            <a:r>
+              <a:t>Comptes : amaury / diana / bob / charlie — mot de passe test1234.</a:t>
+            </a:r>
+          </a:p>
+        </p:txBody>
+      </p:sp>
+      <p:sp>
+        <p:nvSpPr>
+          <p:cNvPr id="4" name="Slide Number Placeholder 3"/>
+          <p:cNvSpPr>
+            <a:spLocks noGrp="1"/>
+          </p:cNvSpPr>
+          <p:nvPr>
+            <p:ph type="sldNum" idx="5" sz="quarter"/>
+          </p:nvPr>
+        </p:nvSpPr>
+        <p:spPr/>
+      </p:sp>
+    </p:spTree>
+  </p:cSld>
+  <p:clrMapOvr>
+    <a:masterClrMapping/>
+  </p:clrMapOvr>
+</p:notes>
+</file>
+
+<file path=ppt/notesSlides/notesSlide11.xml><?xml version="1.0" encoding="utf-8"?>
+<p:notes xmlns:a="http://schemas.openxmlformats.org/drawingml/2006/main" xmlns:p="http://schemas.openxmlformats.org/presentationml/2006/main" xmlns:r="http://schemas.openxmlformats.org/officeDocument/2006/relationships">
+  <p:cSld>
+    <p:spTree>
+      <p:nvGrpSpPr>
+        <p:cNvPr id="1" name=""/>
+        <p:cNvGrpSpPr/>
+        <p:nvPr/>
+      </p:nvGrpSpPr>
+      <p:grpSpPr>
+        <a:xfrm>
+          <a:off x="0" y="0"/>
+          <a:ext cx="0" cy="0"/>
+          <a:chOff x="0" y="0"/>
+          <a:chExt cx="0" cy="0"/>
+        </a:xfrm>
+      </p:grpSpPr>
+      <p:sp>
+        <p:nvSpPr>
+          <p:cNvPr id="2" name="Slide Image Placeholder 1"/>
+          <p:cNvSpPr>
+            <a:spLocks noGrp="1"/>
+          </p:cNvSpPr>
+          <p:nvPr>
+            <p:ph type="sldImg" idx="2"/>
+          </p:nvPr>
+        </p:nvSpPr>
+        <p:spPr/>
+      </p:sp>
+      <p:sp>
+        <p:nvSpPr>
+          <p:cNvPr id="3" name="Notes Placeholder 2"/>
+          <p:cNvSpPr>
+            <a:spLocks noGrp="1"/>
+          </p:cNvSpPr>
+          <p:nvPr>
+            <p:ph type="body" idx="3" sz="quarter"/>
+          </p:nvPr>
+        </p:nvSpPr>
+        <p:spPr/>
+        <p:txBody>
+          <a:bodyPr/>
+          <a:lstStyle/>
+          <a:p>
+            <a:r>
+              <a:t>⏱ 30 secondes  (cumul : 15:00)</a:t>
+            </a:r>
+          </a:p>
+          <a:p/>
+          <a:p>
+            <a:r>
+              <a:t>Conclure en assumant les limites : token simple, polling, capitaine tiré au sort — des choix de périmètre, pas des oublis.</a:t>
+            </a:r>
+          </a:p>
+          <a:p/>
+          <a:p>
+            <a:r>
+              <a:t>Ouvrir sur la suite : le contrat JSON est en place, la réécriture Spring Boot peut se faire sans toucher au client.</a:t>
+            </a:r>
+          </a:p>
+          <a:p/>
+          <a:p>
+            <a:r>
+              <a:t>« Merci — place à la démo. » → lancer demo.bat.</a:t>
+            </a:r>
+          </a:p>
+        </p:txBody>
+      </p:sp>
+      <p:sp>
+        <p:nvSpPr>
+          <p:cNvPr id="4" name="Slide Number Placeholder 3"/>
+          <p:cNvSpPr>
+            <a:spLocks noGrp="1"/>
+          </p:cNvSpPr>
+          <p:nvPr>
+            <p:ph type="sldNum" idx="5" sz="quarter"/>
+          </p:nvPr>
+        </p:nvSpPr>
+        <p:spPr/>
+      </p:sp>
+    </p:spTree>
+  </p:cSld>
+  <p:clrMapOvr>
+    <a:masterClrMapping/>
+  </p:clrMapOvr>
+</p:notes>
+</file>
+
+<file path=ppt/notesSlides/notesSlide2.xml><?xml version="1.0" encoding="utf-8"?>
+<p:notes xmlns:a="http://schemas.openxmlformats.org/drawingml/2006/main" xmlns:p="http://schemas.openxmlformats.org/presentationml/2006/main" xmlns:r="http://schemas.openxmlformats.org/officeDocument/2006/relationships">
+  <p:cSld>
+    <p:spTree>
+      <p:nvGrpSpPr>
+        <p:cNvPr id="1" name=""/>
+        <p:cNvGrpSpPr/>
+        <p:nvPr/>
+      </p:nvGrpSpPr>
+      <p:grpSpPr>
+        <a:xfrm>
+          <a:off x="0" y="0"/>
+          <a:ext cx="0" cy="0"/>
+          <a:chOff x="0" y="0"/>
+          <a:chExt cx="0" cy="0"/>
+        </a:xfrm>
+      </p:grpSpPr>
+      <p:sp>
+        <p:nvSpPr>
+          <p:cNvPr id="2" name="Slide Image Placeholder 1"/>
+          <p:cNvSpPr>
+            <a:spLocks noGrp="1"/>
+          </p:cNvSpPr>
+          <p:nvPr>
+            <p:ph type="sldImg" idx="2"/>
+          </p:nvPr>
+        </p:nvSpPr>
+        <p:spPr/>
+      </p:sp>
+      <p:sp>
+        <p:nvSpPr>
+          <p:cNvPr id="3" name="Notes Placeholder 2"/>
+          <p:cNvSpPr>
+            <a:spLocks noGrp="1"/>
+          </p:cNvSpPr>
+          <p:nvPr>
+            <p:ph type="body" idx="3" sz="quarter"/>
+          </p:nvPr>
+        </p:nvSpPr>
+        <p:spPr/>
+        <p:txBody>
+          <a:bodyPr/>
+          <a:lstStyle/>
+          <a:p>
+            <a:r>
+              <a:t>⏱ 1 min 30  (cumul : 2:00)</a:t>
+            </a:r>
+          </a:p>
+          <a:p/>
+          <a:p>
+            <a:r>
+              <a:t>Rappeler les règles en 3 phrases : deux camps, les loups tuent la nuit, le village vote le jour. La force du jeu c'est le bluff : personne ne connaît le rôle des autres.</a:t>
+            </a:r>
+          </a:p>
+          <a:p/>
+          <a:p>
+            <a:r>
+              <a:t>Balayer les 6 rôles rapidement (les illustrations sont celles utilisées dans le jeu) :</a:t>
+            </a:r>
+          </a:p>
+          <a:p>
+            <a:r>
+              <a:t>- Voyante : sonde un rôle chaque nuit</a:t>
+            </a:r>
+          </a:p>
+          <a:p>
+            <a:r>
+              <a:t>- Sorcière : une potion de vie, une de mort, une seule fois chacune</a:t>
+            </a:r>
+          </a:p>
+          <a:p>
+            <a:r>
+              <a:t>- Chasseur : quand il meurt, il emporte quelqu'un</a:t>
+            </a:r>
+          </a:p>
+          <a:p>
+            <a:r>
+              <a:t>- Petite Fille : espionne le chat des loups — rôle que j'ai ajouté au-delà du sujet</a:t>
+            </a:r>
+          </a:p>
+          <a:p/>
+          <a:p>
+            <a:r>
+              <a:t>Point clé à dire : « le client s'adapte au rôle : chaque joueur voit une interface d'action différente selon ce qu'il est et la phase en cours ».</a:t>
+            </a:r>
+          </a:p>
+        </p:txBody>
+      </p:sp>
+      <p:sp>
+        <p:nvSpPr>
+          <p:cNvPr id="4" name="Slide Number Placeholder 3"/>
+          <p:cNvSpPr>
+            <a:spLocks noGrp="1"/>
+          </p:cNvSpPr>
+          <p:nvPr>
+            <p:ph type="sldNum" idx="5" sz="quarter"/>
+          </p:nvPr>
+        </p:nvSpPr>
+        <p:spPr/>
+      </p:sp>
+    </p:spTree>
+  </p:cSld>
+  <p:clrMapOvr>
+    <a:masterClrMapping/>
+  </p:clrMapOvr>
+</p:notes>
+</file>
+
+<file path=ppt/notesSlides/notesSlide3.xml><?xml version="1.0" encoding="utf-8"?>
+<p:notes xmlns:a="http://schemas.openxmlformats.org/drawingml/2006/main" xmlns:p="http://schemas.openxmlformats.org/presentationml/2006/main" xmlns:r="http://schemas.openxmlformats.org/officeDocument/2006/relationships">
+  <p:cSld>
+    <p:spTree>
+      <p:nvGrpSpPr>
+        <p:cNvPr id="1" name=""/>
+        <p:cNvGrpSpPr/>
+        <p:nvPr/>
+      </p:nvGrpSpPr>
+      <p:grpSpPr>
+        <a:xfrm>
+          <a:off x="0" y="0"/>
+          <a:ext cx="0" cy="0"/>
+          <a:chOff x="0" y="0"/>
+          <a:chExt cx="0" cy="0"/>
+        </a:xfrm>
+      </p:grpSpPr>
+      <p:sp>
+        <p:nvSpPr>
+          <p:cNvPr id="2" name="Slide Image Placeholder 1"/>
+          <p:cNvSpPr>
+            <a:spLocks noGrp="1"/>
+          </p:cNvSpPr>
+          <p:nvPr>
+            <p:ph type="sldImg" idx="2"/>
+          </p:nvPr>
+        </p:nvSpPr>
+        <p:spPr/>
+      </p:sp>
+      <p:sp>
+        <p:nvSpPr>
+          <p:cNvPr id="3" name="Notes Placeholder 2"/>
+          <p:cNvSpPr>
+            <a:spLocks noGrp="1"/>
+          </p:cNvSpPr>
+          <p:nvPr>
+            <p:ph type="body" idx="3" sz="quarter"/>
+          </p:nvPr>
+        </p:nvSpPr>
+        <p:spPr/>
+        <p:txBody>
+          <a:bodyPr/>
+          <a:lstStyle/>
+          <a:p>
+            <a:r>
+              <a:t>⏱ 2 min  (cumul : 4:00)</a:t>
+            </a:r>
+          </a:p>
+          <a:p/>
+          <a:p>
+            <a:r>
+              <a:t>La slide la plus importante côté conception. Dérouler de gauche à droite :</a:t>
+            </a:r>
+          </a:p>
+          <a:p/>
+          <a:p>
+            <a:r>
+              <a:t>1. CLIENT : JavaFX 21, Maven. Tout passe par des Task en arrière-plan, jamais de réseau sur le thread UI. Packagé en fat JAR exécutable (livrable démo).</a:t>
+            </a:r>
+          </a:p>
+          <a:p>
+            <a:r>
+              <a:t>2. API : PHP 8 sans framework — c'est voulu par le sujet (proof of concept, préparation à la réécriture Spring Boot). Un routeur unique, ~30 endpoints JSON, token Bearer stocké en BDD.</a:t>
+            </a:r>
+          </a:p>
+          <a:p>
+            <a:r>
+              <a:t>3. BDD : MySQL via PDO, requêtes préparées partout (pas d'injection SQL).</a:t>
+            </a:r>
+          </a:p>
+          <a:p/>
+          <a:p>
+            <a:r>
+              <a:t>Justifier le polling (encadré du bas) : toutes les 2 secondes le client demande GET /state qui renvoie TOUT l'état. Avantages : simple, robuste, le serveur reste la seule source de vérité. WebSocket serait mieux à grande échelle — assumé en perspective.</a:t>
+            </a:r>
+          </a:p>
+        </p:txBody>
+      </p:sp>
+      <p:sp>
+        <p:nvSpPr>
+          <p:cNvPr id="4" name="Slide Number Placeholder 3"/>
+          <p:cNvSpPr>
+            <a:spLocks noGrp="1"/>
+          </p:cNvSpPr>
+          <p:nvPr>
+            <p:ph type="sldNum" idx="5" sz="quarter"/>
+          </p:nvPr>
+        </p:nvSpPr>
+        <p:spPr/>
+      </p:sp>
+    </p:spTree>
+  </p:cSld>
+  <p:clrMapOvr>
+    <a:masterClrMapping/>
+  </p:clrMapOvr>
+</p:notes>
+</file>
+
+<file path=ppt/notesSlides/notesSlide4.xml><?xml version="1.0" encoding="utf-8"?>
+<p:notes xmlns:a="http://schemas.openxmlformats.org/drawingml/2006/main" xmlns:p="http://schemas.openxmlformats.org/presentationml/2006/main" xmlns:r="http://schemas.openxmlformats.org/officeDocument/2006/relationships">
+  <p:cSld>
+    <p:spTree>
+      <p:nvGrpSpPr>
+        <p:cNvPr id="1" name=""/>
+        <p:cNvGrpSpPr/>
+        <p:nvPr/>
+      </p:nvGrpSpPr>
+      <p:grpSpPr>
+        <a:xfrm>
+          <a:off x="0" y="0"/>
+          <a:ext cx="0" cy="0"/>
+          <a:chOff x="0" y="0"/>
+          <a:chExt cx="0" cy="0"/>
+        </a:xfrm>
+      </p:grpSpPr>
+      <p:sp>
+        <p:nvSpPr>
+          <p:cNvPr id="2" name="Slide Image Placeholder 1"/>
+          <p:cNvSpPr>
+            <a:spLocks noGrp="1"/>
+          </p:cNvSpPr>
+          <p:nvPr>
+            <p:ph type="sldImg" idx="2"/>
+          </p:nvPr>
+        </p:nvSpPr>
+        <p:spPr/>
+      </p:sp>
+      <p:sp>
+        <p:nvSpPr>
+          <p:cNvPr id="3" name="Notes Placeholder 2"/>
+          <p:cNvSpPr>
+            <a:spLocks noGrp="1"/>
+          </p:cNvSpPr>
+          <p:nvPr>
+            <p:ph type="body" idx="3" sz="quarter"/>
+          </p:nvPr>
+        </p:nvSpPr>
+        <p:spPr/>
+        <p:txBody>
+          <a:bodyPr/>
+          <a:lstStyle/>
+          <a:p>
+            <a:r>
+              <a:t>⏱ 1 min  (cumul : 5:00)</a:t>
+            </a:r>
+          </a:p>
+          <a:p/>
+          <a:p>
+            <a:r>
+              <a:t>Ne pas tout lire — donner la logique : 3 domaines.</a:t>
+            </a:r>
+          </a:p>
+          <a:p>
+            <a:r>
+              <a:t>- Cœur du jeu : la partie, les joueurs dans la partie, les votes, les actions de nuit.</a:t>
+            </a:r>
+          </a:p>
+          <a:p>
+            <a:r>
+              <a:t>- Social : comptes, amis, invitations.</a:t>
+            </a:r>
+          </a:p>
+          <a:p>
+            <a:r>
+              <a:t>- Événements : le journal (avec visibilité par camp !) et le chat scopé.</a:t>
+            </a:r>
+          </a:p>
+          <a:p/>
+          <a:p>
+            <a:r>
+              <a:t>Détail qui vaut le coup : la visibilité des rôles est décidée CÔTÉ SERVEUR (phrase du bas). Un client modifié ne peut pas tricher : le JSON ne contient jamais les rôles des vivants.</a:t>
+            </a:r>
+          </a:p>
+          <a:p/>
+          <a:p>
+            <a:r>
+              <a:t>Mentionner : schéma complet pour installer + 5 migrations incrémentales, comme en production.</a:t>
+            </a:r>
+          </a:p>
+        </p:txBody>
+      </p:sp>
+      <p:sp>
+        <p:nvSpPr>
+          <p:cNvPr id="4" name="Slide Number Placeholder 3"/>
+          <p:cNvSpPr>
+            <a:spLocks noGrp="1"/>
+          </p:cNvSpPr>
+          <p:nvPr>
+            <p:ph type="sldNum" idx="5" sz="quarter"/>
+          </p:nvPr>
+        </p:nvSpPr>
+        <p:spPr/>
+      </p:sp>
+    </p:spTree>
+  </p:cSld>
+  <p:clrMapOvr>
+    <a:masterClrMapping/>
+  </p:clrMapOvr>
+</p:notes>
+</file>
+
+<file path=ppt/notesSlides/notesSlide5.xml><?xml version="1.0" encoding="utf-8"?>
+<p:notes xmlns:a="http://schemas.openxmlformats.org/drawingml/2006/main" xmlns:p="http://schemas.openxmlformats.org/presentationml/2006/main" xmlns:r="http://schemas.openxmlformats.org/officeDocument/2006/relationships">
+  <p:cSld>
+    <p:spTree>
+      <p:nvGrpSpPr>
+        <p:cNvPr id="1" name=""/>
+        <p:cNvGrpSpPr/>
+        <p:nvPr/>
+      </p:nvGrpSpPr>
+      <p:grpSpPr>
+        <a:xfrm>
+          <a:off x="0" y="0"/>
+          <a:ext cx="0" cy="0"/>
+          <a:chOff x="0" y="0"/>
+          <a:chExt cx="0" cy="0"/>
+        </a:xfrm>
+      </p:grpSpPr>
+      <p:sp>
+        <p:nvSpPr>
+          <p:cNvPr id="2" name="Slide Image Placeholder 1"/>
+          <p:cNvSpPr>
+            <a:spLocks noGrp="1"/>
+          </p:cNvSpPr>
+          <p:nvPr>
+            <p:ph type="sldImg" idx="2"/>
+          </p:nvPr>
+        </p:nvSpPr>
+        <p:spPr/>
+      </p:sp>
+      <p:sp>
+        <p:nvSpPr>
+          <p:cNvPr id="3" name="Notes Placeholder 2"/>
+          <p:cNvSpPr>
+            <a:spLocks noGrp="1"/>
+          </p:cNvSpPr>
+          <p:nvPr>
+            <p:ph type="body" idx="3" sz="quarter"/>
+          </p:nvPr>
+        </p:nvSpPr>
+        <p:spPr/>
+        <p:txBody>
+          <a:bodyPr/>
+          <a:lstStyle/>
+          <a:p>
+            <a:r>
+              <a:t>⏱ 2 min  (cumul : 7:00)</a:t>
+            </a:r>
+          </a:p>
+          <a:p/>
+          <a:p>
+            <a:r>
+              <a:t>Le moteur du jeu. Suivre les flèches :</a:t>
+            </a:r>
+          </a:p>
+          <a:p>
+            <a:r>
+              <a:t>- Nuit : les loups votent (majorité), la Voyante sonde, la Sorcière décide, puis résolution — les morts sont annoncés au village.</a:t>
+            </a:r>
+          </a:p>
+          <a:p>
+            <a:r>
+              <a:t>- Jour : tout le monde vote, le Capitaine compte double, lynchage, vérification de victoire, et on repart en nuit.</a:t>
+            </a:r>
+          </a:p>
+          <a:p/>
+          <a:p>
+            <a:r>
+              <a:t>Deux mécanismes à souligner :</a:t>
+            </a:r>
+          </a:p>
+          <a:p>
+            <a:r>
+              <a:t>1. Une phase avance dès que tous les concernés ont joué OU quand le timer expire → un joueur AFK ne bloque jamais la partie.</a:t>
+            </a:r>
+          </a:p>
+          <a:p>
+            <a:r>
+              <a:t>2. La pause Chasseur : s'il meurt, la machine à états SE FIGE 30 s le temps qu'il choisisse sa cible — c'est le seul cas où le jeu attend un joueur.</a:t>
+            </a:r>
+          </a:p>
+          <a:p/>
+          <a:p>
+            <a:r>
+              <a:t>Tout ça est côté serveur : le client ne fait qu'afficher.</a:t>
+            </a:r>
+          </a:p>
+        </p:txBody>
+      </p:sp>
+      <p:sp>
+        <p:nvSpPr>
+          <p:cNvPr id="4" name="Slide Number Placeholder 3"/>
+          <p:cNvSpPr>
+            <a:spLocks noGrp="1"/>
+          </p:cNvSpPr>
+          <p:nvPr>
+            <p:ph type="sldNum" idx="5" sz="quarter"/>
+          </p:nvPr>
+        </p:nvSpPr>
+        <p:spPr/>
+      </p:sp>
+    </p:spTree>
+  </p:cSld>
+  <p:clrMapOvr>
+    <a:masterClrMapping/>
+  </p:clrMapOvr>
+</p:notes>
+</file>
+
+<file path=ppt/notesSlides/notesSlide6.xml><?xml version="1.0" encoding="utf-8"?>
+<p:notes xmlns:a="http://schemas.openxmlformats.org/drawingml/2006/main" xmlns:p="http://schemas.openxmlformats.org/presentationml/2006/main" xmlns:r="http://schemas.openxmlformats.org/officeDocument/2006/relationships">
+  <p:cSld>
+    <p:spTree>
+      <p:nvGrpSpPr>
+        <p:cNvPr id="1" name=""/>
+        <p:cNvGrpSpPr/>
+        <p:nvPr/>
+      </p:nvGrpSpPr>
+      <p:grpSpPr>
+        <a:xfrm>
+          <a:off x="0" y="0"/>
+          <a:ext cx="0" cy="0"/>
+          <a:chOff x="0" y="0"/>
+          <a:chExt cx="0" cy="0"/>
+        </a:xfrm>
+      </p:grpSpPr>
+      <p:sp>
+        <p:nvSpPr>
+          <p:cNvPr id="2" name="Slide Image Placeholder 1"/>
+          <p:cNvSpPr>
+            <a:spLocks noGrp="1"/>
+          </p:cNvSpPr>
+          <p:nvPr>
+            <p:ph type="sldImg" idx="2"/>
+          </p:nvPr>
+        </p:nvSpPr>
+        <p:spPr/>
+      </p:sp>
+      <p:sp>
+        <p:nvSpPr>
+          <p:cNvPr id="3" name="Notes Placeholder 2"/>
+          <p:cNvSpPr>
+            <a:spLocks noGrp="1"/>
+          </p:cNvSpPr>
+          <p:nvPr>
+            <p:ph type="body" idx="3" sz="quarter"/>
+          </p:nvPr>
+        </p:nvSpPr>
+        <p:spPr/>
+        <p:txBody>
+          <a:bodyPr/>
+          <a:lstStyle/>
+          <a:p>
+            <a:r>
+              <a:t>⏱ 1 min 30  (cumul : 8:30)</a:t>
+            </a:r>
+          </a:p>
+          <a:p/>
+          <a:p>
+            <a:r>
+              <a:t>Mapping direct avec le cahier des charges — chaque composant demandé est utilisé pour un vrai besoin du jeu, pas artificiellement :</a:t>
+            </a:r>
+          </a:p>
+          <a:p>
+            <a:r>
+              <a:t>- TreeView : vivants / éliminés</a:t>
+            </a:r>
+          </a:p>
+          <a:p>
+            <a:r>
+              <a:t>- ProgressBar : le timer, qui vire au rouge et pulse sous 10 secondes</a:t>
+            </a:r>
+          </a:p>
+          <a:p>
+            <a:r>
+              <a:t>- Dialog : la vision de la Voyante avec l'illustration du rôle</a:t>
+            </a:r>
+          </a:p>
+          <a:p>
+            <a:r>
+              <a:t>- Timeline : le polling ET le compte à rebours local resynchronisé à chaque réponse serveur</a:t>
+            </a:r>
+          </a:p>
+          <a:p/>
+          <a:p>
+            <a:r>
+              <a:t>Mentionner les sons : 5 ambiances jouées par AudioClip — je les ai SYNTHÉTISÉS en Python (libres de droits par construction), le script est dans le dépôt.</a:t>
+            </a:r>
+          </a:p>
+        </p:txBody>
+      </p:sp>
+      <p:sp>
+        <p:nvSpPr>
+          <p:cNvPr id="4" name="Slide Number Placeholder 3"/>
+          <p:cNvSpPr>
+            <a:spLocks noGrp="1"/>
+          </p:cNvSpPr>
+          <p:nvPr>
+            <p:ph type="sldNum" idx="5" sz="quarter"/>
+          </p:nvPr>
+        </p:nvSpPr>
+        <p:spPr/>
+      </p:sp>
+    </p:spTree>
+  </p:cSld>
+  <p:clrMapOvr>
+    <a:masterClrMapping/>
+  </p:clrMapOvr>
+</p:notes>
+</file>
+
+<file path=ppt/notesSlides/notesSlide7.xml><?xml version="1.0" encoding="utf-8"?>
+<p:notes xmlns:a="http://schemas.openxmlformats.org/drawingml/2006/main" xmlns:p="http://schemas.openxmlformats.org/presentationml/2006/main" xmlns:r="http://schemas.openxmlformats.org/officeDocument/2006/relationships">
+  <p:cSld>
+    <p:spTree>
+      <p:nvGrpSpPr>
+        <p:cNvPr id="1" name=""/>
+        <p:cNvGrpSpPr/>
+        <p:nvPr/>
+      </p:nvGrpSpPr>
+      <p:grpSpPr>
+        <a:xfrm>
+          <a:off x="0" y="0"/>
+          <a:ext cx="0" cy="0"/>
+          <a:chOff x="0" y="0"/>
+          <a:chExt cx="0" cy="0"/>
+        </a:xfrm>
+      </p:grpSpPr>
+      <p:sp>
+        <p:nvSpPr>
+          <p:cNvPr id="2" name="Slide Image Placeholder 1"/>
+          <p:cNvSpPr>
+            <a:spLocks noGrp="1"/>
+          </p:cNvSpPr>
+          <p:nvPr>
+            <p:ph type="sldImg" idx="2"/>
+          </p:nvPr>
+        </p:nvSpPr>
+        <p:spPr/>
+      </p:sp>
+      <p:sp>
+        <p:nvSpPr>
+          <p:cNvPr id="3" name="Notes Placeholder 2"/>
+          <p:cNvSpPr>
+            <a:spLocks noGrp="1"/>
+          </p:cNvSpPr>
+          <p:nvPr>
+            <p:ph type="body" idx="3" sz="quarter"/>
+          </p:nvPr>
+        </p:nvSpPr>
+        <p:spPr/>
+        <p:txBody>
+          <a:bodyPr/>
+          <a:lstStyle/>
+          <a:p>
+            <a:r>
+              <a:t>⏱ 1 min 30  (cumul : 10:00)</a:t>
+            </a:r>
+          </a:p>
+          <a:p/>
+          <a:p>
+            <a:r>
+              <a:t>Tout ça n'était pas demandé — c'est ce qui rend les parties vivantes :</a:t>
+            </a:r>
+          </a:p>
+          <a:p>
+            <a:r>
+              <a:t>- Capitaine et Petite Fille : de la profondeur de gameplay (voix double, espionnage)</a:t>
+            </a:r>
+          </a:p>
+          <a:p>
+            <a:r>
+              <a:t>- Chat scopé : les loups complotent en privé la nuit ; les morts deviennent spectateurs et voient tout</a:t>
+            </a:r>
+          </a:p>
+          <a:p>
+            <a:r>
+              <a:t>- ELO : vraie formule K=32 par équipe, avec historique et leaderboard</a:t>
+            </a:r>
+          </a:p>
+          <a:p>
+            <a:r>
+              <a:t>- Social complet : amis, invitations en partie</a:t>
+            </a:r>
+          </a:p>
+          <a:p/>
+          <a:p>
+            <a:r>
+              <a:t>Ne pas s'attarder : la démo les montrera en vrai.</a:t>
+            </a:r>
+          </a:p>
+        </p:txBody>
+      </p:sp>
+      <p:sp>
+        <p:nvSpPr>
+          <p:cNvPr id="4" name="Slide Number Placeholder 3"/>
+          <p:cNvSpPr>
+            <a:spLocks noGrp="1"/>
+          </p:cNvSpPr>
+          <p:nvPr>
+            <p:ph type="sldNum" idx="5" sz="quarter"/>
+          </p:nvPr>
+        </p:nvSpPr>
+        <p:spPr/>
+      </p:sp>
+    </p:spTree>
+  </p:cSld>
+  <p:clrMapOvr>
+    <a:masterClrMapping/>
+  </p:clrMapOvr>
+</p:notes>
+</file>
+
+<file path=ppt/notesSlides/notesSlide8.xml><?xml version="1.0" encoding="utf-8"?>
+<p:notes xmlns:a="http://schemas.openxmlformats.org/drawingml/2006/main" xmlns:p="http://schemas.openxmlformats.org/presentationml/2006/main" xmlns:r="http://schemas.openxmlformats.org/officeDocument/2006/relationships">
+  <p:cSld>
+    <p:spTree>
+      <p:nvGrpSpPr>
+        <p:cNvPr id="1" name=""/>
+        <p:cNvGrpSpPr/>
+        <p:nvPr/>
+      </p:nvGrpSpPr>
+      <p:grpSpPr>
+        <a:xfrm>
+          <a:off x="0" y="0"/>
+          <a:ext cx="0" cy="0"/>
+          <a:chOff x="0" y="0"/>
+          <a:chExt cx="0" cy="0"/>
+        </a:xfrm>
+      </p:grpSpPr>
+      <p:sp>
+        <p:nvSpPr>
+          <p:cNvPr id="2" name="Slide Image Placeholder 1"/>
+          <p:cNvSpPr>
+            <a:spLocks noGrp="1"/>
+          </p:cNvSpPr>
+          <p:nvPr>
+            <p:ph type="sldImg" idx="2"/>
+          </p:nvPr>
+        </p:nvSpPr>
+        <p:spPr/>
+      </p:sp>
+      <p:sp>
+        <p:nvSpPr>
+          <p:cNvPr id="3" name="Notes Placeholder 2"/>
+          <p:cNvSpPr>
+            <a:spLocks noGrp="1"/>
+          </p:cNvSpPr>
+          <p:nvPr>
+            <p:ph type="body" idx="3" sz="quarter"/>
+          </p:nvPr>
+        </p:nvSpPr>
+        <p:spPr/>
+        <p:txBody>
+          <a:bodyPr/>
+          <a:lstStyle/>
+          <a:p>
+            <a:r>
+              <a:t>⏱ 2 min  (cumul : 12:00)</a:t>
+            </a:r>
+          </a:p>
+          <a:p/>
+          <a:p>
+            <a:r>
+              <a:t>Le mode entraînement : jouer seul contre des bots qui jouent vraiment toutes les phases.</a:t>
+            </a:r>
+          </a:p>
+          <a:p/>
+          <a:p>
+            <a:r>
+              <a:t>Partie technique à raconter :</a:t>
+            </a:r>
+          </a:p>
+          <a:p>
+            <a:r>
+              <a:t>- Les dialogues sont générés par Google Gemini avec un prompt contextuel : le bot connaît son rôle secret, les vivants, les derniers événements et le chat récent.</a:t>
+            </a:r>
+          </a:p>
+          <a:p>
+            <a:r>
+              <a:t>- Chaque bot a une personnalité stable (déterministe sur son id) : lire les citations à droite — Iris est « silencieuse », ça se voit.</a:t>
+            </a:r>
+          </a:p>
+          <a:p>
+            <a:r>
+              <a:t>- Les loups bots ne révèlent jamais leur rôle : c'est dans le prompt.</a:t>
+            </a:r>
+          </a:p>
+          <a:p>
+            <a:r>
+              <a:t>- Garde-fous : throttle 3 s par partie, timeout 8 s, et si pas de clé API → phrases pré-écrites. Le jeu ne dépend jamais de l'IA.</a:t>
+            </a:r>
+          </a:p>
+          <a:p/>
+          <a:p>
+            <a:r>
+              <a:t>Sécurité : la clé vit dans config.local.php, ignoré par Git.</a:t>
+            </a:r>
+          </a:p>
+        </p:txBody>
+      </p:sp>
+      <p:sp>
+        <p:nvSpPr>
+          <p:cNvPr id="4" name="Slide Number Placeholder 3"/>
+          <p:cNvSpPr>
+            <a:spLocks noGrp="1"/>
+          </p:cNvSpPr>
+          <p:nvPr>
+            <p:ph type="sldNum" idx="5" sz="quarter"/>
+          </p:nvPr>
+        </p:nvSpPr>
+        <p:spPr/>
+      </p:sp>
+    </p:spTree>
+  </p:cSld>
+  <p:clrMapOvr>
+    <a:masterClrMapping/>
+  </p:clrMapOvr>
+</p:notes>
+</file>
+
+<file path=ppt/notesSlides/notesSlide9.xml><?xml version="1.0" encoding="utf-8"?>
+<p:notes xmlns:a="http://schemas.openxmlformats.org/drawingml/2006/main" xmlns:p="http://schemas.openxmlformats.org/presentationml/2006/main" xmlns:r="http://schemas.openxmlformats.org/officeDocument/2006/relationships">
+  <p:cSld>
+    <p:spTree>
+      <p:nvGrpSpPr>
+        <p:cNvPr id="1" name=""/>
+        <p:cNvGrpSpPr/>
+        <p:nvPr/>
+      </p:nvGrpSpPr>
+      <p:grpSpPr>
+        <a:xfrm>
+          <a:off x="0" y="0"/>
+          <a:ext cx="0" cy="0"/>
+          <a:chOff x="0" y="0"/>
+          <a:chExt cx="0" cy="0"/>
+        </a:xfrm>
+      </p:grpSpPr>
+      <p:sp>
+        <p:nvSpPr>
+          <p:cNvPr id="2" name="Slide Image Placeholder 1"/>
+          <p:cNvSpPr>
+            <a:spLocks noGrp="1"/>
+          </p:cNvSpPr>
+          <p:nvPr>
+            <p:ph type="sldImg" idx="2"/>
+          </p:nvPr>
+        </p:nvSpPr>
+        <p:spPr/>
+      </p:sp>
+      <p:sp>
+        <p:nvSpPr>
+          <p:cNvPr id="3" name="Notes Placeholder 2"/>
+          <p:cNvSpPr>
+            <a:spLocks noGrp="1"/>
+          </p:cNvSpPr>
+          <p:nvPr>
+            <p:ph type="body" idx="3" sz="quarter"/>
+          </p:nvPr>
+        </p:nvSpPr>
+        <p:spPr/>
+        <p:txBody>
+          <a:bodyPr/>
+          <a:lstStyle/>
+          <a:p>
+            <a:r>
+              <a:t>⏱ 2 min  (cumul : 14:00)</a:t>
+            </a:r>
+          </a:p>
+          <a:p/>
+          <a:p>
+            <a:r>
+              <a:t>La slide « honnêteté technique » — raconter une ou deux histoires, pas les quatre :</a:t>
+            </a:r>
+          </a:p>
+          <a:p/>
+          <a:p>
+            <a:r>
+              <a:t>★ La meilleure : les loups ne tuaient JAMAIS personne. Le « passer » de la Sorcière était enregistré comme un faux soin → chaque nuit était annulée. Je l'ai trouvé en écrivant une simulation de partie complète via l'API (curl). Leçon : tester le système de bout en bout, pas seulement les endpoints un par un.</a:t>
+            </a:r>
+          </a:p>
+          <a:p/>
+          <a:p>
+            <a:r>
+              <a:t>★ En secours : le Connection refused — php -S localhost écoutait en IPv6, le client Java appelait en IPv4. Leçon : toujours être explicite sur le binding réseau.</a:t>
+            </a:r>
+          </a:p>
+          <a:p/>
+          <a:p>
+            <a:r>
+              <a:t>Si question sur le JAR ou Gemini, les deux autres cartes servent d'appui.</a:t>
+            </a:r>
+          </a:p>
+        </p:txBody>
+      </p:sp>
+      <p:sp>
+        <p:nvSpPr>
+          <p:cNvPr id="4" name="Slide Number Placeholder 3"/>
+          <p:cNvSpPr>
+            <a:spLocks noGrp="1"/>
+          </p:cNvSpPr>
+          <p:nvPr>
+            <p:ph type="sldNum" idx="5" sz="quarter"/>
+          </p:nvPr>
+        </p:nvSpPr>
+        <p:spPr/>
+      </p:sp>
+    </p:spTree>
+  </p:cSld>
+  <p:clrMapOvr>
+    <a:masterClrMapping/>
+  </p:clrMapOvr>
+</p:notes>
 </file>
 
 <file path=ppt/slideLayouts/slideLayout1.xml><?xml version="1.0" encoding="utf-8"?>
@@ -12369,4 +13806,324 @@
   </a:objectDefaults>
   <a:extraClrSchemeLst/>
 </a:theme>
+</file>
+
+<file path=ppt/theme/theme2.xml><?xml version="1.0" encoding="utf-8"?>
+<a:theme xmlns:a="http://schemas.openxmlformats.org/drawingml/2006/main" name="Office Theme">
+  <a:themeElements>
+    <a:clrScheme name="Office">
+      <a:dk1>
+        <a:sysClr val="windowText" lastClr="000000"/>
+      </a:dk1>
+      <a:lt1>
+        <a:sysClr val="window" lastClr="FFFFFF"/>
+      </a:lt1>
+      <a:dk2>
+        <a:srgbClr val="1F497D"/>
+      </a:dk2>
+      <a:lt2>
+        <a:srgbClr val="EEECE1"/>
+      </a:lt2>
+      <a:accent1>
+        <a:srgbClr val="4F81BD"/>
+      </a:accent1>
+      <a:accent2>
+        <a:srgbClr val="C0504D"/>
+      </a:accent2>
+      <a:accent3>
+        <a:srgbClr val="9BBB59"/>
+      </a:accent3>
+      <a:accent4>
+        <a:srgbClr val="8064A2"/>
+      </a:accent4>
+      <a:accent5>
+        <a:srgbClr val="4BACC6"/>
+      </a:accent5>
+      <a:accent6>
+        <a:srgbClr val="F79646"/>
+      </a:accent6>
+      <a:hlink>
+        <a:srgbClr val="0000FF"/>
+      </a:hlink>
+      <a:folHlink>
+        <a:srgbClr val="800080"/>
+      </a:folHlink>
+    </a:clrScheme>
+    <a:fontScheme name="Office">
+      <a:majorFont>
+        <a:latin typeface="Calibri"/>
+        <a:ea typeface=""/>
+        <a:cs typeface=""/>
+        <a:font script="Jpan" typeface="ＭＳ Ｐゴシック"/>
+        <a:font script="Hang" typeface="맑은 고딕"/>
+        <a:font script="Hans" typeface="宋体"/>
+        <a:font script="Hant" typeface="新細明體"/>
+        <a:font script="Arab" typeface="Times New Roman"/>
+        <a:font script="Hebr" typeface="Times New Roman"/>
+        <a:font script="Thai" typeface="Angsana New"/>
+        <a:font script="Ethi" typeface="Nyala"/>
+        <a:font script="Beng" typeface="Vrinda"/>
+        <a:font script="Gujr" typeface="Shruti"/>
+        <a:font script="Khmr" typeface="MoolBoran"/>
+        <a:font script="Knda" typeface="Tunga"/>
+        <a:font script="Guru" typeface="Raavi"/>
+        <a:font script="Cans" typeface="Euphemia"/>
+        <a:font script="Cher" typeface="Plantagenet Cherokee"/>
+        <a:font script="Yiii" typeface="Microsoft Yi Baiti"/>
+        <a:font script="Tibt" typeface="Microsoft Himalaya"/>
+        <a:font script="Thaa" typeface="MV Boli"/>
+        <a:font script="Deva" typeface="Mangal"/>
+        <a:font script="Telu" typeface="Gautami"/>
+        <a:font script="Taml" typeface="Latha"/>
+        <a:font script="Syrc" typeface="Estrangelo Edessa"/>
+        <a:font script="Orya" typeface="Kalinga"/>
+        <a:font script="Mlym" typeface="Kartika"/>
+        <a:font script="Laoo" typeface="DokChampa"/>
+        <a:font script="Sinh" typeface="Iskoola Pota"/>
+        <a:font script="Mong" typeface="Mongolian Baiti"/>
+        <a:font script="Viet" typeface="Times New Roman"/>
+        <a:font script="Uigh" typeface="Microsoft Uighur"/>
+        <a:font script="Geor" typeface="Sylfaen"/>
+      </a:majorFont>
+      <a:minorFont>
+        <a:latin typeface="Calibri"/>
+        <a:ea typeface=""/>
+        <a:cs typeface=""/>
+        <a:font script="Jpan" typeface="ＭＳ Ｐゴシック"/>
+        <a:font script="Hang" typeface="맑은 고딕"/>
+        <a:font script="Hans" typeface="宋体"/>
+        <a:font script="Hant" typeface="新細明體"/>
+        <a:font script="Arab" typeface="Arial"/>
+        <a:font script="Hebr" typeface="Arial"/>
+        <a:font script="Thai" typeface="Cordia New"/>
+        <a:font script="Ethi" typeface="Nyala"/>
+        <a:font script="Beng" typeface="Vrinda"/>
+        <a:font script="Gujr" typeface="Shruti"/>
+        <a:font script="Khmr" typeface="DaunPenh"/>
+        <a:font script="Knda" typeface="Tunga"/>
+        <a:font script="Guru" typeface="Raavi"/>
+        <a:font script="Cans" typeface="Euphemia"/>
+        <a:font script="Cher" typeface="Plantagenet Cherokee"/>
+        <a:font script="Yiii" typeface="Microsoft Yi Baiti"/>
+        <a:font script="Tibt" typeface="Microsoft Himalaya"/>
+        <a:font script="Thaa" typeface="MV Boli"/>
+        <a:font script="Deva" typeface="Mangal"/>
+        <a:font script="Telu" typeface="Gautami"/>
+        <a:font script="Taml" typeface="Latha"/>
+        <a:font script="Syrc" typeface="Estrangelo Edessa"/>
+        <a:font script="Orya" typeface="Kalinga"/>
+        <a:font script="Mlym" typeface="Kartika"/>
+        <a:font script="Laoo" typeface="DokChampa"/>
+        <a:font script="Sinh" typeface="Iskoola Pota"/>
+        <a:font script="Mong" typeface="Mongolian Baiti"/>
+        <a:font script="Viet" typeface="Arial"/>
+        <a:font script="Uigh" typeface="Microsoft Uighur"/>
+        <a:font script="Geor" typeface="Sylfaen"/>
+      </a:minorFont>
+    </a:fontScheme>
+    <a:fmtScheme name="Office">
+      <a:fillStyleLst>
+        <a:solidFill>
+          <a:schemeClr val="phClr"/>
+        </a:solidFill>
+        <a:gradFill rotWithShape="1">
+          <a:gsLst>
+            <a:gs pos="0">
+              <a:schemeClr val="phClr">
+                <a:tint val="50000"/>
+                <a:satMod val="300000"/>
+              </a:schemeClr>
+            </a:gs>
+            <a:gs pos="35000">
+              <a:schemeClr val="phClr">
+                <a:tint val="37000"/>
+                <a:satMod val="300000"/>
+              </a:schemeClr>
+            </a:gs>
+            <a:gs pos="100000">
+              <a:schemeClr val="phClr">
+                <a:tint val="15000"/>
+                <a:satMod val="350000"/>
+              </a:schemeClr>
+            </a:gs>
+          </a:gsLst>
+          <a:lin ang="16200000" scaled="1"/>
+        </a:gradFill>
+        <a:gradFill rotWithShape="1">
+          <a:gsLst>
+            <a:gs pos="0">
+              <a:schemeClr val="phClr">
+                <a:tint val="100000"/>
+                <a:shade val="100000"/>
+                <a:satMod val="130000"/>
+              </a:schemeClr>
+            </a:gs>
+            <a:gs pos="100000">
+              <a:schemeClr val="phClr">
+                <a:tint val="50000"/>
+                <a:shade val="100000"/>
+                <a:satMod val="350000"/>
+              </a:schemeClr>
+            </a:gs>
+          </a:gsLst>
+          <a:lin ang="16200000" scaled="0"/>
+        </a:gradFill>
+      </a:fillStyleLst>
+      <a:lnStyleLst>
+        <a:ln w="9525" cap="flat" cmpd="sng" algn="ctr">
+          <a:solidFill>
+            <a:schemeClr val="phClr">
+              <a:shade val="95000"/>
+              <a:satMod val="105000"/>
+            </a:schemeClr>
+          </a:solidFill>
+          <a:prstDash val="solid"/>
+        </a:ln>
+        <a:ln w="25400" cap="flat" cmpd="sng" algn="ctr">
+          <a:solidFill>
+            <a:schemeClr val="phClr"/>
+          </a:solidFill>
+          <a:prstDash val="solid"/>
+        </a:ln>
+        <a:ln w="38100" cap="flat" cmpd="sng" algn="ctr">
+          <a:solidFill>
+            <a:schemeClr val="phClr"/>
+          </a:solidFill>
+          <a:prstDash val="solid"/>
+        </a:ln>
+      </a:lnStyleLst>
+      <a:effectStyleLst>
+        <a:effectStyle>
+          <a:effectLst>
+            <a:outerShdw blurRad="40000" dist="20000" dir="5400000" rotWithShape="0">
+              <a:srgbClr val="000000">
+                <a:alpha val="38000"/>
+              </a:srgbClr>
+            </a:outerShdw>
+          </a:effectLst>
+        </a:effectStyle>
+        <a:effectStyle>
+          <a:effectLst>
+            <a:outerShdw blurRad="40000" dist="23000" dir="5400000" rotWithShape="0">
+              <a:srgbClr val="000000">
+                <a:alpha val="35000"/>
+              </a:srgbClr>
+            </a:outerShdw>
+          </a:effectLst>
+        </a:effectStyle>
+        <a:effectStyle>
+          <a:effectLst>
+            <a:outerShdw blurRad="40000" dist="23000" dir="5400000" rotWithShape="0">
+              <a:srgbClr val="000000">
+                <a:alpha val="35000"/>
+              </a:srgbClr>
+            </a:outerShdw>
+          </a:effectLst>
+          <a:scene3d>
+            <a:camera prst="orthographicFront">
+              <a:rot lat="0" lon="0" rev="0"/>
+            </a:camera>
+            <a:lightRig rig="threePt" dir="t">
+              <a:rot lat="0" lon="0" rev="1200000"/>
+            </a:lightRig>
+          </a:scene3d>
+          <a:sp3d>
+            <a:bevelT w="63500" h="25400"/>
+          </a:sp3d>
+        </a:effectStyle>
+      </a:effectStyleLst>
+      <a:bgFillStyleLst>
+        <a:solidFill>
+          <a:schemeClr val="phClr"/>
+        </a:solidFill>
+        <a:gradFill rotWithShape="1">
+          <a:gsLst>
+            <a:gs pos="0">
+              <a:schemeClr val="phClr">
+                <a:tint val="40000"/>
+                <a:satMod val="350000"/>
+              </a:schemeClr>
+            </a:gs>
+            <a:gs pos="40000">
+              <a:schemeClr val="phClr">
+                <a:tint val="45000"/>
+                <a:shade val="99000"/>
+                <a:satMod val="350000"/>
+              </a:schemeClr>
+            </a:gs>
+            <a:gs pos="100000">
+              <a:schemeClr val="phClr">
+                <a:shade val="20000"/>
+                <a:satMod val="255000"/>
+              </a:schemeClr>
+            </a:gs>
+          </a:gsLst>
+          <a:path path="circle">
+            <a:fillToRect l="50000" t="-80000" r="50000" b="180000"/>
+          </a:path>
+        </a:gradFill>
+        <a:gradFill rotWithShape="1">
+          <a:gsLst>
+            <a:gs pos="0">
+              <a:schemeClr val="phClr">
+                <a:tint val="80000"/>
+                <a:satMod val="300000"/>
+              </a:schemeClr>
+            </a:gs>
+            <a:gs pos="100000">
+              <a:schemeClr val="phClr">
+                <a:shade val="30000"/>
+                <a:satMod val="200000"/>
+              </a:schemeClr>
+            </a:gs>
+          </a:gsLst>
+          <a:path path="circle">
+            <a:fillToRect l="50000" t="50000" r="50000" b="50000"/>
+          </a:path>
+        </a:gradFill>
+      </a:bgFillStyleLst>
+    </a:fmtScheme>
+  </a:themeElements>
+  <a:objectDefaults>
+    <a:spDef>
+      <a:spPr/>
+      <a:bodyPr/>
+      <a:lstStyle/>
+      <a:style>
+        <a:lnRef idx="1">
+          <a:schemeClr val="accent1"/>
+        </a:lnRef>
+        <a:fillRef idx="3">
+          <a:schemeClr val="accent1"/>
+        </a:fillRef>
+        <a:effectRef idx="2">
+          <a:schemeClr val="accent1"/>
+        </a:effectRef>
+        <a:fontRef idx="minor">
+          <a:schemeClr val="lt1"/>
+        </a:fontRef>
+      </a:style>
+    </a:spDef>
+    <a:lnDef>
+      <a:spPr/>
+      <a:bodyPr/>
+      <a:lstStyle/>
+      <a:style>
+        <a:lnRef idx="2">
+          <a:schemeClr val="accent1"/>
+        </a:lnRef>
+        <a:fillRef idx="0">
+          <a:schemeClr val="accent1"/>
+        </a:fillRef>
+        <a:effectRef idx="1">
+          <a:schemeClr val="accent1"/>
+        </a:effectRef>
+        <a:fontRef idx="minor">
+          <a:schemeClr val="tx1"/>
+        </a:fontRef>
+      </a:style>
+    </a:lnDef>
+  </a:objectDefaults>
+  <a:extraClrSchemeLst/>
+</a:theme>
 </file>
</xml_diff>

<commit_message>
Soutenance : notes réécrites en script oral mot à mot
</commit_message>
<xml_diff>
--- a/Soutenance_Loup-Garou.pptx
+++ b/Soutenance_Loup-Garou.pptx
@@ -512,25 +512,25 @@
           <a:lstStyle/>
           <a:p>
             <a:r>
-              <a:t>⏱ 30 secondes  (cumul : 0:30)</a:t>
+              <a:t>⏱ 30 s  (cumul : 0:30)</a:t>
             </a:r>
           </a:p>
           <a:p/>
           <a:p>
             <a:r>
-              <a:t>Bonjour, je vais vous présenter mon projet : une adaptation multijoueur du Loup-Garou de Thiercelieux, en client lourd.</a:t>
+              <a:t>Bonjour. Je vais vous présenter mon projet de jeu multijoueur : une adaptation du Loup-Garou de Thiercelieux, en client lourd JavaFX, connecté à une API REST en PHP avec une base MySQL.</a:t>
             </a:r>
           </a:p>
           <a:p/>
           <a:p>
             <a:r>
-              <a:t>C'est un projet que j'ai réalisé seul : le client JavaFX, l'API PHP et la base de données.</a:t>
+              <a:t>J'ai réalisé ce projet seul : le client, l'API et la base de données.</a:t>
             </a:r>
           </a:p>
           <a:p/>
           <a:p>
             <a:r>
-              <a:t>Annonce du plan : le jeu, l'architecture, la technique, les difficultés, puis la démo live.</a:t>
+              <a:t>Je vais vous parler du jeu lui-même, de l'architecture, des choix techniques, des difficultés que j'ai rencontrées, et je terminerai par une démonstration en direct.</a:t>
             </a:r>
           </a:p>
         </p:txBody>
@@ -600,25 +600,19 @@
           <a:lstStyle/>
           <a:p>
             <a:r>
-              <a:t>⏱ 30 secondes  (cumul : 14:30)</a:t>
+              <a:t>⏱ 30 s  (cumul : 14:30)</a:t>
             </a:r>
           </a:p>
           <a:p/>
           <a:p>
             <a:r>
-              <a:t>Transition vers la démo — annoncer simplement le programme des 4 étapes et les points à observer (colonne de droite).</a:t>
+              <a:t>Voici le programme de la démonstration, en quatre temps. D'abord une partie à quatre joueurs, avec quatre fenêtres du client côte à côte — chacune avec son propre compte et son propre rôle secret. Ensuite une nuit complète, puis un vote du village. Et je terminerai par le mode entraînement contre les bots.</a:t>
             </a:r>
           </a:p>
           <a:p/>
           <a:p>
             <a:r>
-              <a:t>Logistique déjà prête : demo.bat lance la BDD, l'API et les 4 fenêtres d'un coup.</a:t>
-            </a:r>
-          </a:p>
-          <a:p/>
-          <a:p>
-            <a:r>
-              <a:t>Comptes : amaury / diana / bob / charlie — mot de passe test1234.</a:t>
+              <a:t>Pendant la démo, je vous invite à garder un œil sur les éléments listés à droite : les composants d'interface, les animations, les sons et le chat des loups.</a:t>
             </a:r>
           </a:p>
         </p:txBody>
@@ -688,25 +682,25 @@
           <a:lstStyle/>
           <a:p>
             <a:r>
-              <a:t>⏱ 30 secondes  (cumul : 15:00)</a:t>
+              <a:t>⏱ 30 s  (cumul : 15:00)</a:t>
             </a:r>
           </a:p>
           <a:p/>
           <a:p>
             <a:r>
-              <a:t>Conclure en assumant les limites : token simple, polling, capitaine tiré au sort — des choix de périmètre, pas des oublis.</a:t>
+              <a:t>Pour conclure, un mot sur les limites — elles sont assumées. Le token d'authentification est simple, sans expiration. Le polling remplace le WebSocket. Le Capitaine est tiré au sort plutôt qu'élu. Ce sont des choix de périmètre pour un proof of concept, pas des oublis.</a:t>
             </a:r>
           </a:p>
           <a:p/>
           <a:p>
             <a:r>
-              <a:t>Ouvrir sur la suite : le contrat JSON est en place, la réécriture Spring Boot peut se faire sans toucher au client.</a:t>
+              <a:t>Et la suite est déjà préparée : le contrat d'interface JSON est en place, donc la réécriture du backend en Spring Boot pourra se faire sans toucher une ligne du client.</a:t>
             </a:r>
           </a:p>
           <a:p/>
           <a:p>
             <a:r>
-              <a:t>« Merci — place à la démo. » → lancer demo.bat.</a:t>
+              <a:t>Merci de votre attention — place à la démo.</a:t>
             </a:r>
           </a:p>
         </p:txBody>
@@ -782,39 +776,19 @@
           <a:p/>
           <a:p>
             <a:r>
-              <a:t>Rappeler les règles en 3 phrases : deux camps, les loups tuent la nuit, le village vote le jour. La force du jeu c'est le bluff : personne ne connaît le rôle des autres.</a:t>
+              <a:t>Pour ceux qui ne connaissent pas le jeu, les règles tiennent en trois phrases. Deux camps s'affrontent : les Loups-Garous et le Village. La nuit, les loups désignent secrètement une victime. Le jour, tout le village vote pour éliminer un suspect. Le dernier camp debout gagne. Toute la force du jeu, c'est le bluff : personne ne connaît le rôle des autres.</a:t>
             </a:r>
           </a:p>
           <a:p/>
           <a:p>
             <a:r>
-              <a:t>Balayer les 6 rôles rapidement (les illustrations sont celles utilisées dans le jeu) :</a:t>
-            </a:r>
-          </a:p>
-          <a:p>
-            <a:r>
-              <a:t>- Voyante : sonde un rôle chaque nuit</a:t>
-            </a:r>
-          </a:p>
-          <a:p>
-            <a:r>
-              <a:t>- Sorcière : une potion de vie, une de mort, une seule fois chacune</a:t>
-            </a:r>
-          </a:p>
-          <a:p>
-            <a:r>
-              <a:t>- Chasseur : quand il meurt, il emporte quelqu'un</a:t>
-            </a:r>
-          </a:p>
-          <a:p>
-            <a:r>
-              <a:t>- Petite Fille : espionne le chat des loups — rôle que j'ai ajouté au-delà du sujet</a:t>
+              <a:t>Une partie se joue de 4 à 10 joueurs, avec six rôles. Le Villageois, qui n'a que sa déduction. Le Loup-Garou, qui chasse la nuit. La Voyante, qui peut sonder le rôle d'un joueur chaque nuit. La Sorcière, qui possède deux potions : une pour sauver, une pour tuer, utilisables une seule fois. Le Chasseur, qui, quand il meurt, emporte quelqu'un avec lui. Et la Petite Fille, un rôle que j'ai ajouté au-delà du sujet : elle peut espionner les loups pendant la nuit.</a:t>
             </a:r>
           </a:p>
           <a:p/>
           <a:p>
             <a:r>
-              <a:t>Point clé à dire : « le client s'adapte au rôle : chaque joueur voit une interface d'action différente selon ce qu'il est et la phase en cours ».</a:t>
+              <a:t>Les illustrations que vous voyez sont celles utilisées dans le jeu. Et un point important : le client s'adapte au rôle. Chaque joueur voit une interface d'action différente selon ce qu'il est et selon la phase en cours.</a:t>
             </a:r>
           </a:p>
         </p:txBody>
@@ -890,29 +864,31 @@
           <a:p/>
           <a:p>
             <a:r>
-              <a:t>La slide la plus importante côté conception. Dérouler de gauche à droite :</a:t>
+              <a:t>Voici l'architecture globale, en trois blocs, de gauche à droite.</a:t>
             </a:r>
           </a:p>
           <a:p/>
           <a:p>
             <a:r>
-              <a:t>1. CLIENT : JavaFX 21, Maven. Tout passe par des Task en arrière-plan, jamais de réseau sur le thread UI. Packagé en fat JAR exécutable (livrable démo).</a:t>
-            </a:r>
-          </a:p>
-          <a:p>
-            <a:r>
-              <a:t>2. API : PHP 8 sans framework — c'est voulu par le sujet (proof of concept, préparation à la réécriture Spring Boot). Un routeur unique, ~30 endpoints JSON, token Bearer stocké en BDD.</a:t>
-            </a:r>
-          </a:p>
-          <a:p>
-            <a:r>
-              <a:t>3. BDD : MySQL via PDO, requêtes préparées partout (pas d'injection SQL).</a:t>
+              <a:t>D'abord le client : JavaFX 21, construit avec Maven. Toutes les requêtes réseau passent par des Task en arrière-plan — je ne fais jamais de réseau sur le thread d'interface, donc l'application ne gèle jamais. Le client est packagé en fat JAR exécutable : un simple java -jar suffit pour le lancer sur n'importe quelle machine avec un JDK 17.</a:t>
             </a:r>
           </a:p>
           <a:p/>
           <a:p>
             <a:r>
-              <a:t>Justifier le polling (encadré du bas) : toutes les 2 secondes le client demande GET /state qui renvoie TOUT l'état. Avantages : simple, robuste, le serveur reste la seule source de vérité. WebSocket serait mieux à grande échelle — assumé en perspective.</a:t>
+              <a:t>Ensuite l'API : du PHP 8 sans framework, et c'est un choix voulu par le sujet — c'est un proof of concept qui prépare la réécriture en Spring Boot. Un routeur unique reçoit toutes les requêtes et les distribue vers une trentaine d'endpoints JSON. L'authentification se fait par token Bearer stocké en base.</a:t>
+            </a:r>
+          </a:p>
+          <a:p/>
+          <a:p>
+            <a:r>
+              <a:t>Enfin la base de données : MySQL, attaquée via PDO avec des requêtes préparées partout — donc pas d'injection SQL possible.</a:t>
+            </a:r>
+          </a:p>
+          <a:p/>
+          <a:p>
+            <a:r>
+              <a:t>Un mot sur le choix du polling plutôt que du WebSocket. Toutes les deux secondes, le client demande GET /state, et le serveur renvoie l'état complet de la partie. C'est simple, c'est robuste, c'est facile à débugger, et surtout le serveur reste la seule source de vérité : le client ne fait qu'afficher. Pour 4 à 10 joueurs, c'est largement suffisant. Le WebSocket serait le bon choix à plus grande échelle — j'y reviendrai en perspective.</a:t>
             </a:r>
           </a:p>
         </p:txBody>
@@ -988,34 +964,25 @@
           <a:p/>
           <a:p>
             <a:r>
-              <a:t>Ne pas tout lire — donner la logique : 3 domaines.</a:t>
-            </a:r>
-          </a:p>
-          <a:p>
-            <a:r>
-              <a:t>- Cœur du jeu : la partie, les joueurs dans la partie, les votes, les actions de nuit.</a:t>
-            </a:r>
-          </a:p>
-          <a:p>
-            <a:r>
-              <a:t>- Social : comptes, amis, invitations.</a:t>
-            </a:r>
-          </a:p>
-          <a:p>
-            <a:r>
-              <a:t>- Événements : le journal (avec visibilité par camp !) et le chat scopé.</a:t>
+              <a:t>Le modèle de données : neuf tables, organisées en trois domaines.</a:t>
             </a:r>
           </a:p>
           <a:p/>
           <a:p>
             <a:r>
-              <a:t>Détail qui vaut le coup : la visibilité des rôles est décidée CÔTÉ SERVEUR (phrase du bas). Un client modifié ne peut pas tricher : le JSON ne contient jamais les rôles des vivants.</a:t>
+              <a:t>Le cœur du jeu : la partie elle-même, les joueurs dans la partie avec leur rôle, les votes, et les actions de nuit. Le domaine social : les comptes, les amis, les invitations. Et les événements : le journal de partie et le chat.</a:t>
             </a:r>
           </a:p>
           <a:p/>
           <a:p>
             <a:r>
-              <a:t>Mentionner : schéma complet pour installer + 5 migrations incrémentales, comme en production.</a:t>
+              <a:t>Je veux attirer votre attention sur un point : la visibilité des rôles est décidée côté serveur. Tant qu'un joueur est vivant, son rôle ne part jamais dans le JSON. Donc même avec un client modifié, il est impossible de tricher.</a:t>
+            </a:r>
+          </a:p>
+          <a:p/>
+          <a:p>
+            <a:r>
+              <a:t>Enfin, pour l'installation : un schéma complet pour partir de zéro, et cinq migrations incrémentales pour mettre à jour une base existante — comme on le ferait en production.</a:t>
             </a:r>
           </a:p>
         </p:txBody>
@@ -1091,39 +1058,31 @@
           <a:p/>
           <a:p>
             <a:r>
-              <a:t>Le moteur du jeu. Suivre les flèches :</a:t>
-            </a:r>
-          </a:p>
-          <a:p>
-            <a:r>
-              <a:t>- Nuit : les loups votent (majorité), la Voyante sonde, la Sorcière décide, puis résolution — les morts sont annoncés au village.</a:t>
-            </a:r>
-          </a:p>
-          <a:p>
-            <a:r>
-              <a:t>- Jour : tout le monde vote, le Capitaine compte double, lynchage, vérification de victoire, et on repart en nuit.</a:t>
+              <a:t>Voici le moteur du jeu : une machine à états, entièrement côté serveur.</a:t>
             </a:r>
           </a:p>
           <a:p/>
           <a:p>
             <a:r>
-              <a:t>Deux mécanismes à souligner :</a:t>
-            </a:r>
-          </a:p>
-          <a:p>
-            <a:r>
-              <a:t>1. Une phase avance dès que tous les concernés ont joué OU quand le timer expire → un joueur AFK ne bloque jamais la partie.</a:t>
-            </a:r>
-          </a:p>
-          <a:p>
-            <a:r>
-              <a:t>2. La pause Chasseur : s'il meurt, la machine à états SE FIGE 30 s le temps qu'il choisisse sa cible — c'est le seul cas où le jeu attend un joueur.</a:t>
+              <a:t>La nuit d'abord, en 45 secondes. Les loups se réveillent et votent pour une victime — c'est la majorité qui l'emporte. Puis la Voyante sonde le rôle d'un joueur. Puis la Sorcière décide : sauver la victime, empoisonner quelqu'un, ou ne rien faire. Et enfin la résolution : les morts de la nuit sont annoncés au village, et on vérifie si un camp a gagné.</a:t>
             </a:r>
           </a:p>
           <a:p/>
           <a:p>
             <a:r>
-              <a:t>Tout ça est côté serveur : le client ne fait qu'afficher.</a:t>
+              <a:t>Le jour ensuite, en 60 secondes. Tout le village vote, avec une subtilité : la voix du Capitaine compte double. Le joueur désigné est éliminé, son rôle est révélé, on vérifie la victoire, et la nuit retombe.</a:t>
+            </a:r>
+          </a:p>
+          <a:p/>
+          <a:p>
+            <a:r>
+              <a:t>Deux mécanismes méritent d'être soulignés. Premièrement, une phase avance dès que tous les joueurs concernés ont joué, ou quand le timer expire. Conséquence : un joueur absent ne bloque jamais la partie. Deuxièmement, la pause Chasseur : si le Chasseur meurt, la machine à états se fige pendant 30 secondes, le temps qu'il choisisse qui emporter avec lui. C'est le seul cas où le jeu attend un joueur.</a:t>
+            </a:r>
+          </a:p>
+          <a:p/>
+          <a:p>
+            <a:r>
+              <a:t>Et j'insiste : toute cette logique est côté serveur. Le client ne fait qu'afficher l'état et proposer des actions.</a:t>
             </a:r>
           </a:p>
         </p:txBody>
@@ -1199,33 +1158,25 @@
           <a:p/>
           <a:p>
             <a:r>
-              <a:t>Mapping direct avec le cahier des charges — chaque composant demandé est utilisé pour un vrai besoin du jeu, pas artificiellement :</a:t>
-            </a:r>
-          </a:p>
-          <a:p>
-            <a:r>
-              <a:t>- TreeView : vivants / éliminés</a:t>
-            </a:r>
-          </a:p>
-          <a:p>
-            <a:r>
-              <a:t>- ProgressBar : le timer, qui vire au rouge et pulse sous 10 secondes</a:t>
-            </a:r>
-          </a:p>
-          <a:p>
-            <a:r>
-              <a:t>- Dialog : la vision de la Voyante avec l'illustration du rôle</a:t>
-            </a:r>
-          </a:p>
-          <a:p>
-            <a:r>
-              <a:t>- Timeline : le polling ET le compte à rebours local resynchronisé à chaque réponse serveur</a:t>
+              <a:t>Cette slide fait le lien direct avec le cahier des charges : chaque composant demandé est utilisé pour un vrai besoin du jeu, pas artificiellement.</a:t>
             </a:r>
           </a:p>
           <a:p/>
           <a:p>
             <a:r>
-              <a:t>Mentionner les sons : 5 ambiances jouées par AudioClip — je les ai SYNTHÉTISÉS en Python (libres de droits par construction), le script est dans le dépôt.</a:t>
+              <a:t>Le TreeView affiche les joueurs vivants et éliminés, avec les tags de l'hôte et du Capitaine. Les ListView et ComboBox servent au choix des cibles selon le rôle. La ProgressBar anime le timer de phase — et sous les 10 dernières secondes, elle vire au rouge et le compteur pulse, pour mettre la pression. Les Dialog affichent la vision de la Voyante avec l'illustration du rôle, le tir du Chasseur et la fin de partie.</a:t>
+            </a:r>
+          </a:p>
+          <a:p/>
+          <a:p>
+            <a:r>
+              <a:t>Côté animations : une Timeline gère le polling toutes les deux secondes, une autre le compte à rebours local, resynchronisé à chaque réponse du serveur. Et des transitions de fondu et de translation accompagnent le passage jour-nuit, avec le lever de la lune et du soleil.</a:t>
+            </a:r>
+          </a:p>
+          <a:p/>
+          <a:p>
+            <a:r>
+              <a:t>Un mot sur les sons : cinq ambiances jouées par AudioClip — la nuit, l'aube, le hurlement de loup, la mort et la victoire. Je les ai synthétisés en Python, ce qui les rend libres de droits par construction. Le script de génération est dans le dépôt.</a:t>
             </a:r>
           </a:p>
         </p:txBody>
@@ -1301,33 +1252,37 @@
           <a:p/>
           <a:p>
             <a:r>
-              <a:t>Tout ça n'était pas demandé — c'est ce qui rend les parties vivantes :</a:t>
-            </a:r>
-          </a:p>
-          <a:p>
-            <a:r>
-              <a:t>- Capitaine et Petite Fille : de la profondeur de gameplay (voix double, espionnage)</a:t>
-            </a:r>
-          </a:p>
-          <a:p>
-            <a:r>
-              <a:t>- Chat scopé : les loups complotent en privé la nuit ; les morts deviennent spectateurs et voient tout</a:t>
-            </a:r>
-          </a:p>
-          <a:p>
-            <a:r>
-              <a:t>- ELO : vraie formule K=32 par équipe, avec historique et leaderboard</a:t>
-            </a:r>
-          </a:p>
-          <a:p>
-            <a:r>
-              <a:t>- Social complet : amis, invitations en partie</a:t>
+              <a:t>Tout ce que vous voyez sur cette slide n'était pas demandé dans le sujet — c'est ce que j'ai ajouté pour rendre les parties vivantes.</a:t>
             </a:r>
           </a:p>
           <a:p/>
           <a:p>
             <a:r>
-              <a:t>Ne pas s'attarder : la démo les montrera en vrai.</a:t>
+              <a:t>Deux rôles supplémentaires : le Capitaine, désigné au démarrage, dont la voix compte double au vote, et qui transmet son écharpe à un survivant quand il meurt. Et la Petite Fille, qui lit le chat des loups pendant la nuit — à elle d'exploiter l'information sans se faire griller.</a:t>
+            </a:r>
+          </a:p>
+          <a:p/>
+          <a:p>
+            <a:r>
+              <a:t>Le Chasseur est entièrement interactif : à sa mort, une fenêtre de tir s'ouvre et la partie l'attend 30 secondes.</a:t>
+            </a:r>
+          </a:p>
+          <a:p/>
+          <a:p>
+            <a:r>
+              <a:t>Le chat est scopé : un canal village public, et un canal privé pour les loups la nuit. Les morts, eux, deviennent spectateurs : ils voient tous les rôles et tous les canaux.</a:t>
+            </a:r>
+          </a:p>
+          <a:p/>
+          <a:p>
+            <a:r>
+              <a:t>Et autour du jeu : un classement ELO avec la vraie formule, K égal 32, calculé par équipe sur les parties classées, un historique, un leaderboard, et un système social complet avec amis et invitations en partie.</a:t>
+            </a:r>
+          </a:p>
+          <a:p/>
+          <a:p>
+            <a:r>
+              <a:t>Je ne m'attarde pas : vous verrez tout ça en vrai dans la démo.</a:t>
             </a:r>
           </a:p>
         </p:txBody>
@@ -1403,39 +1358,31 @@
           <a:p/>
           <a:p>
             <a:r>
-              <a:t>Le mode entraînement : jouer seul contre des bots qui jouent vraiment toutes les phases.</a:t>
+              <a:t>Pour pouvoir jouer seul, j'ai développé un mode entraînement contre des bots. Et ce ne sont pas des figurants : ils jouent vraiment toutes les phases. Les loups bots votent en meute la nuit, la sorcière bot gère ses potions, et si un chasseur bot meurt, il riposte.</a:t>
             </a:r>
           </a:p>
           <a:p/>
           <a:p>
             <a:r>
-              <a:t>Partie technique à raconter :</a:t>
-            </a:r>
-          </a:p>
-          <a:p>
-            <a:r>
-              <a:t>- Les dialogues sont générés par Google Gemini avec un prompt contextuel : le bot connaît son rôle secret, les vivants, les derniers événements et le chat récent.</a:t>
-            </a:r>
-          </a:p>
-          <a:p>
-            <a:r>
-              <a:t>- Chaque bot a une personnalité stable (déterministe sur son id) : lire les citations à droite — Iris est « silencieuse », ça se voit.</a:t>
-            </a:r>
-          </a:p>
-          <a:p>
-            <a:r>
-              <a:t>- Les loups bots ne révèlent jamais leur rôle : c'est dans le prompt.</a:t>
-            </a:r>
-          </a:p>
-          <a:p>
-            <a:r>
-              <a:t>- Garde-fous : throttle 3 s par partie, timeout 8 s, et si pas de clé API → phrases pré-écrites. Le jeu ne dépend jamais de l'IA.</a:t>
+              <a:t>La partie la plus intéressante, ce sont les dialogues. Ils sont générés par l'IA Google Gemini, avec un prompt contextuel : le bot connaît son rôle secret, la liste des vivants, les derniers événements de la partie et le chat récent. Il réagit donc à ce qui se passe réellement.</a:t>
             </a:r>
           </a:p>
           <a:p/>
           <a:p>
             <a:r>
-              <a:t>Sécurité : la clé vit dans config.local.php, ignoré par Git.</a:t>
+              <a:t>Chaque bot a une personnalité stable — agressif, peureux, analytique, silencieux… Vous pouvez le voir dans les citations à droite : Iris a le caractère silencieux, et ça se voit — elle répond « Humm. Qui. » Et les loups bots ne révèlent jamais leur rôle : c'est une consigne dans le prompt, ils bluffent.</a:t>
+            </a:r>
+          </a:p>
+          <a:p/>
+          <a:p>
+            <a:r>
+              <a:t>Bien sûr, il y a des garde-fous : maximum un message d'IA toutes les trois secondes par partie, un timeout de huit secondes sur l'appel, et si aucune clé API n'est configurée, les bots retombent sur des phrases pré-écrites. Le jeu ne dépend jamais de l'IA pour fonctionner.</a:t>
+            </a:r>
+          </a:p>
+          <a:p/>
+          <a:p>
+            <a:r>
+              <a:t>Dernier point, la sécurité : la clé API vit dans un fichier de configuration local ignoré par Git — le dépôt ne contient aucun secret.</a:t>
             </a:r>
           </a:p>
         </p:txBody>
@@ -1511,25 +1458,25 @@
           <a:p/>
           <a:p>
             <a:r>
-              <a:t>La slide « honnêteté technique » — raconter une ou deux histoires, pas les quatre :</a:t>
+              <a:t>Je voudrais partager les difficultés les plus formatrices du projet. Je vais vous en raconter deux.</a:t>
             </a:r>
           </a:p>
           <a:p/>
           <a:p>
             <a:r>
-              <a:t>★ La meilleure : les loups ne tuaient JAMAIS personne. Le « passer » de la Sorcière était enregistré comme un faux soin → chaque nuit était annulée. Je l'ai trouvé en écrivant une simulation de partie complète via l'API (curl). Leçon : tester le système de bout en bout, pas seulement les endpoints un par un.</a:t>
+              <a:t>La première, c'est mon bug préféré : à un moment, les loups ne tuaient jamais personne. Chaque nuit, le journal affichait « aucune victime, étrange »... et c'était effectivement étrange. La cause : quand la Sorcière choisissait de ne rien faire, son « passer » était enregistré en base comme un faux soin, juste pour marquer qu'elle avait joué. Et ce faux soin annulait l'attaque des loups, toutes les nuits. Je l'ai trouvé en écrivant une simulation de partie complète à travers l'API — pas en testant les endpoints un par un, mais en jouant une vraie partie de bout en bout. La leçon que j'en tire : c'est le système entier qu'il faut tester, pas ses morceaux.</a:t>
             </a:r>
           </a:p>
           <a:p/>
           <a:p>
             <a:r>
-              <a:t>★ En secours : le Connection refused — php -S localhost écoutait en IPv6, le client Java appelait en IPv4. Leçon : toujours être explicite sur le binding réseau.</a:t>
+              <a:t>La deuxième : un « Connection refused » au login, alors que le serveur tournait parfaitement. En fait, le serveur PHP lancé avec « localhost » s'était lié uniquement en IPv6, alors que le client Java appelait en IPv4. Deux protocoles, deux mondes, aucun contact. La solution : un bind explicite en 127.0.0.1 des deux côtés. Leçon : toujours être explicite sur le binding réseau.</a:t>
             </a:r>
           </a:p>
           <a:p/>
           <a:p>
             <a:r>
-              <a:t>Si question sur le JAR ou Gemini, les deux autres cartes servent d'appui.</a:t>
+              <a:t>Les deux autres cartes — le packaging du JAR JavaFX et le modèle Gemini retiré par Google — je vous laisse les lire, et j'y répondrai volontiers en questions.</a:t>
             </a:r>
           </a:p>
         </p:txBody>

</xml_diff>